<commit_message>
Document Managed Kubernetes Cluster deployment scenario
</commit_message>
<xml_diff>
--- a/profiles/community/tosca/abstract/platform/images/sources/platforms.pptx
+++ b/profiles/community/tosca/abstract/platform/images/sources/platforms.pptx
@@ -14,6 +14,7 @@
     <p:sldId id="282" r:id="rId8"/>
     <p:sldId id="281" r:id="rId9"/>
     <p:sldId id="277" r:id="rId10"/>
+    <p:sldId id="283" r:id="rId11"/>
   </p:sldIdLst>
   <p:sldSz cx="12192000" cy="6858000"/>
   <p:notesSz cx="6858000" cy="9144000"/>
@@ -267,7 +268,7 @@
           <a:p>
             <a:fld id="{5BAF7096-B8B4-4A3B-8A26-165AAEF12400}" type="datetimeFigureOut">
               <a:rPr lang="en-US" smtClean="0"/>
-              <a:t>3/31/2026</a:t>
+              <a:t>4/7/2026</a:t>
             </a:fld>
             <a:endParaRPr lang="en-US"/>
           </a:p>
@@ -465,7 +466,7 @@
           <a:p>
             <a:fld id="{5BAF7096-B8B4-4A3B-8A26-165AAEF12400}" type="datetimeFigureOut">
               <a:rPr lang="en-US" smtClean="0"/>
-              <a:t>3/31/2026</a:t>
+              <a:t>4/7/2026</a:t>
             </a:fld>
             <a:endParaRPr lang="en-US"/>
           </a:p>
@@ -673,7 +674,7 @@
           <a:p>
             <a:fld id="{5BAF7096-B8B4-4A3B-8A26-165AAEF12400}" type="datetimeFigureOut">
               <a:rPr lang="en-US" smtClean="0"/>
-              <a:t>3/31/2026</a:t>
+              <a:t>4/7/2026</a:t>
             </a:fld>
             <a:endParaRPr lang="en-US"/>
           </a:p>
@@ -871,7 +872,7 @@
           <a:p>
             <a:fld id="{5BAF7096-B8B4-4A3B-8A26-165AAEF12400}" type="datetimeFigureOut">
               <a:rPr lang="en-US" smtClean="0"/>
-              <a:t>3/31/2026</a:t>
+              <a:t>4/7/2026</a:t>
             </a:fld>
             <a:endParaRPr lang="en-US"/>
           </a:p>
@@ -1146,7 +1147,7 @@
           <a:p>
             <a:fld id="{5BAF7096-B8B4-4A3B-8A26-165AAEF12400}" type="datetimeFigureOut">
               <a:rPr lang="en-US" smtClean="0"/>
-              <a:t>3/31/2026</a:t>
+              <a:t>4/7/2026</a:t>
             </a:fld>
             <a:endParaRPr lang="en-US"/>
           </a:p>
@@ -1411,7 +1412,7 @@
           <a:p>
             <a:fld id="{5BAF7096-B8B4-4A3B-8A26-165AAEF12400}" type="datetimeFigureOut">
               <a:rPr lang="en-US" smtClean="0"/>
-              <a:t>3/31/2026</a:t>
+              <a:t>4/7/2026</a:t>
             </a:fld>
             <a:endParaRPr lang="en-US"/>
           </a:p>
@@ -1823,7 +1824,7 @@
           <a:p>
             <a:fld id="{5BAF7096-B8B4-4A3B-8A26-165AAEF12400}" type="datetimeFigureOut">
               <a:rPr lang="en-US" smtClean="0"/>
-              <a:t>3/31/2026</a:t>
+              <a:t>4/7/2026</a:t>
             </a:fld>
             <a:endParaRPr lang="en-US"/>
           </a:p>
@@ -1964,7 +1965,7 @@
           <a:p>
             <a:fld id="{5BAF7096-B8B4-4A3B-8A26-165AAEF12400}" type="datetimeFigureOut">
               <a:rPr lang="en-US" smtClean="0"/>
-              <a:t>3/31/2026</a:t>
+              <a:t>4/7/2026</a:t>
             </a:fld>
             <a:endParaRPr lang="en-US"/>
           </a:p>
@@ -2077,7 +2078,7 @@
           <a:p>
             <a:fld id="{5BAF7096-B8B4-4A3B-8A26-165AAEF12400}" type="datetimeFigureOut">
               <a:rPr lang="en-US" smtClean="0"/>
-              <a:t>3/31/2026</a:t>
+              <a:t>4/7/2026</a:t>
             </a:fld>
             <a:endParaRPr lang="en-US"/>
           </a:p>
@@ -2388,7 +2389,7 @@
           <a:p>
             <a:fld id="{5BAF7096-B8B4-4A3B-8A26-165AAEF12400}" type="datetimeFigureOut">
               <a:rPr lang="en-US" smtClean="0"/>
-              <a:t>3/31/2026</a:t>
+              <a:t>4/7/2026</a:t>
             </a:fld>
             <a:endParaRPr lang="en-US"/>
           </a:p>
@@ -2676,7 +2677,7 @@
           <a:p>
             <a:fld id="{5BAF7096-B8B4-4A3B-8A26-165AAEF12400}" type="datetimeFigureOut">
               <a:rPr lang="en-US" smtClean="0"/>
-              <a:t>3/31/2026</a:t>
+              <a:t>4/7/2026</a:t>
             </a:fld>
             <a:endParaRPr lang="en-US"/>
           </a:p>
@@ -2917,7 +2918,7 @@
           <a:p>
             <a:fld id="{5BAF7096-B8B4-4A3B-8A26-165AAEF12400}" type="datetimeFigureOut">
               <a:rPr lang="en-US" smtClean="0"/>
-              <a:t>3/31/2026</a:t>
+              <a:t>4/7/2026</a:t>
             </a:fld>
             <a:endParaRPr lang="en-US"/>
           </a:p>
@@ -3758,6 +3759,999 @@
     <p:extLst>
       <p:ext uri="{BB962C8B-B14F-4D97-AF65-F5344CB8AC3E}">
         <p14:creationId xmlns:p14="http://schemas.microsoft.com/office/powerpoint/2010/main" val="1160173518"/>
+      </p:ext>
+    </p:extLst>
+  </p:cSld>
+  <p:clrMapOvr>
+    <a:masterClrMapping/>
+  </p:clrMapOvr>
+</p:sld>
+</file>
+
+<file path=ppt/slides/slide10.xml><?xml version="1.0" encoding="utf-8"?>
+<p:sld xmlns:a="http://schemas.openxmlformats.org/drawingml/2006/main" xmlns:r="http://schemas.openxmlformats.org/officeDocument/2006/relationships" xmlns:p="http://schemas.openxmlformats.org/presentationml/2006/main">
+  <p:cSld>
+    <p:spTree>
+      <p:nvGrpSpPr>
+        <p:cNvPr id="1" name=""/>
+        <p:cNvGrpSpPr/>
+        <p:nvPr/>
+      </p:nvGrpSpPr>
+      <p:grpSpPr>
+        <a:xfrm>
+          <a:off x="0" y="0"/>
+          <a:ext cx="0" cy="0"/>
+          <a:chOff x="0" y="0"/>
+          <a:chExt cx="0" cy="0"/>
+        </a:xfrm>
+      </p:grpSpPr>
+      <p:grpSp>
+        <p:nvGrpSpPr>
+          <p:cNvPr id="2" name="Group 1">
+            <a:extLst>
+              <a:ext uri="{FF2B5EF4-FFF2-40B4-BE49-F238E27FC236}">
+                <a16:creationId xmlns:a16="http://schemas.microsoft.com/office/drawing/2014/main" id="{8165D0B7-B119-73EE-16D6-BE83092F115C}"/>
+              </a:ext>
+            </a:extLst>
+          </p:cNvPr>
+          <p:cNvGrpSpPr/>
+          <p:nvPr/>
+        </p:nvGrpSpPr>
+        <p:grpSpPr>
+          <a:xfrm>
+            <a:off x="5710290" y="2244919"/>
+            <a:ext cx="771421" cy="2368163"/>
+            <a:chOff x="5710290" y="3520515"/>
+            <a:chExt cx="771421" cy="2368163"/>
+          </a:xfrm>
+        </p:grpSpPr>
+        <p:grpSp>
+          <p:nvGrpSpPr>
+            <p:cNvPr id="18" name="Group 17">
+              <a:extLst>
+                <a:ext uri="{FF2B5EF4-FFF2-40B4-BE49-F238E27FC236}">
+                  <a16:creationId xmlns:a16="http://schemas.microsoft.com/office/drawing/2014/main" id="{0965E86A-1C94-A558-145A-CBC2E89E62AD}"/>
+                </a:ext>
+              </a:extLst>
+            </p:cNvPr>
+            <p:cNvGrpSpPr/>
+            <p:nvPr/>
+          </p:nvGrpSpPr>
+          <p:grpSpPr>
+            <a:xfrm>
+              <a:off x="5710290" y="4897646"/>
+              <a:ext cx="771421" cy="991032"/>
+              <a:chOff x="3816079" y="4223863"/>
+              <a:chExt cx="771421" cy="991032"/>
+            </a:xfrm>
+          </p:grpSpPr>
+          <p:sp>
+            <p:nvSpPr>
+              <p:cNvPr id="19" name="Rectangle 18">
+                <a:extLst>
+                  <a:ext uri="{FF2B5EF4-FFF2-40B4-BE49-F238E27FC236}">
+                    <a16:creationId xmlns:a16="http://schemas.microsoft.com/office/drawing/2014/main" id="{D1423ABE-B95A-39BF-B25A-51AE295D7BCC}"/>
+                  </a:ext>
+                </a:extLst>
+              </p:cNvPr>
+              <p:cNvSpPr/>
+              <p:nvPr/>
+            </p:nvSpPr>
+            <p:spPr>
+              <a:xfrm>
+                <a:off x="3816079" y="4722603"/>
+                <a:ext cx="771421" cy="250978"/>
+              </a:xfrm>
+              <a:prstGeom prst="rect">
+                <a:avLst/>
+              </a:prstGeom>
+              <a:solidFill>
+                <a:schemeClr val="bg1">
+                  <a:lumMod val="95000"/>
+                </a:schemeClr>
+              </a:solidFill>
+              <a:ln w="19050">
+                <a:solidFill>
+                  <a:schemeClr val="bg2"/>
+                </a:solidFill>
+              </a:ln>
+            </p:spPr>
+            <p:style>
+              <a:lnRef idx="2">
+                <a:schemeClr val="accent1">
+                  <a:shade val="50000"/>
+                </a:schemeClr>
+              </a:lnRef>
+              <a:fillRef idx="1">
+                <a:schemeClr val="accent1"/>
+              </a:fillRef>
+              <a:effectRef idx="0">
+                <a:schemeClr val="accent1"/>
+              </a:effectRef>
+              <a:fontRef idx="minor">
+                <a:schemeClr val="lt1"/>
+              </a:fontRef>
+            </p:style>
+            <p:txBody>
+              <a:bodyPr lIns="0" rIns="0" rtlCol="0" anchor="ctr"/>
+              <a:lstStyle/>
+              <a:p>
+                <a:pPr marL="0" marR="0" lvl="0" indent="0" algn="ctr" defTabSz="914400" rtl="0" eaLnBrk="1" fontAlgn="auto" latinLnBrk="0" hangingPunct="1">
+                  <a:lnSpc>
+                    <a:spcPct val="100000"/>
+                  </a:lnSpc>
+                  <a:spcBef>
+                    <a:spcPts val="0"/>
+                  </a:spcBef>
+                  <a:spcAft>
+                    <a:spcPts val="0"/>
+                  </a:spcAft>
+                  <a:buClrTx/>
+                  <a:buSzTx/>
+                  <a:buFontTx/>
+                  <a:buNone/>
+                  <a:tabLst/>
+                  <a:defRPr/>
+                </a:pPr>
+                <a:r>
+                  <a:rPr kumimoji="0" lang="en-US" sz="900" b="0" i="0" u="none" strike="noStrike" kern="1200" cap="none" spc="0" normalizeH="0" baseline="0" noProof="0" dirty="0">
+                    <a:ln>
+                      <a:noFill/>
+                    </a:ln>
+                    <a:solidFill>
+                      <a:prstClr val="black"/>
+                    </a:solidFill>
+                    <a:effectLst/>
+                    <a:uLnTx/>
+                    <a:uFillTx/>
+                    <a:ea typeface="+mn-ea"/>
+                    <a:cs typeface="+mn-cs"/>
+                  </a:rPr>
+                  <a:t>Virtualization</a:t>
+                </a:r>
+              </a:p>
+              <a:p>
+                <a:pPr marL="0" marR="0" lvl="0" indent="0" algn="ctr" defTabSz="914400" rtl="0" eaLnBrk="1" fontAlgn="auto" latinLnBrk="0" hangingPunct="1">
+                  <a:lnSpc>
+                    <a:spcPct val="100000"/>
+                  </a:lnSpc>
+                  <a:spcBef>
+                    <a:spcPts val="0"/>
+                  </a:spcBef>
+                  <a:spcAft>
+                    <a:spcPts val="0"/>
+                  </a:spcAft>
+                  <a:buClrTx/>
+                  <a:buSzTx/>
+                  <a:buFontTx/>
+                  <a:buNone/>
+                  <a:tabLst/>
+                  <a:defRPr/>
+                </a:pPr>
+                <a:r>
+                  <a:rPr kumimoji="0" lang="en-US" sz="900" b="0" i="0" u="none" strike="noStrike" kern="1200" cap="none" spc="0" normalizeH="0" baseline="0" noProof="0" dirty="0">
+                    <a:ln>
+                      <a:noFill/>
+                    </a:ln>
+                    <a:solidFill>
+                      <a:prstClr val="black"/>
+                    </a:solidFill>
+                    <a:effectLst/>
+                    <a:uLnTx/>
+                    <a:uFillTx/>
+                    <a:ea typeface="+mn-ea"/>
+                    <a:cs typeface="+mn-cs"/>
+                  </a:rPr>
+                  <a:t>Platform</a:t>
+                </a:r>
+              </a:p>
+            </p:txBody>
+          </p:sp>
+          <p:sp>
+            <p:nvSpPr>
+              <p:cNvPr id="20" name="Rectangle: Rounded Corners 19">
+                <a:extLst>
+                  <a:ext uri="{FF2B5EF4-FFF2-40B4-BE49-F238E27FC236}">
+                    <a16:creationId xmlns:a16="http://schemas.microsoft.com/office/drawing/2014/main" id="{78CF353B-5D46-A40D-867F-63CF5553D636}"/>
+                  </a:ext>
+                </a:extLst>
+              </p:cNvPr>
+              <p:cNvSpPr/>
+              <p:nvPr/>
+            </p:nvSpPr>
+            <p:spPr>
+              <a:xfrm>
+                <a:off x="3816080" y="4399416"/>
+                <a:ext cx="771420" cy="815479"/>
+              </a:xfrm>
+              <a:prstGeom prst="roundRect">
+                <a:avLst/>
+              </a:prstGeom>
+              <a:noFill/>
+              <a:ln w="19050">
+                <a:solidFill>
+                  <a:schemeClr val="tx1"/>
+                </a:solidFill>
+              </a:ln>
+            </p:spPr>
+            <p:style>
+              <a:lnRef idx="2">
+                <a:schemeClr val="accent1">
+                  <a:shade val="50000"/>
+                </a:schemeClr>
+              </a:lnRef>
+              <a:fillRef idx="1">
+                <a:schemeClr val="accent1"/>
+              </a:fillRef>
+              <a:effectRef idx="0">
+                <a:schemeClr val="accent1"/>
+              </a:effectRef>
+              <a:fontRef idx="minor">
+                <a:schemeClr val="lt1"/>
+              </a:fontRef>
+            </p:style>
+            <p:txBody>
+              <a:bodyPr lIns="45720" tIns="0" bIns="9144" rtlCol="0" anchor="b" anchorCtr="0"/>
+              <a:lstStyle/>
+              <a:p>
+                <a:pPr lvl="0">
+                  <a:defRPr/>
+                </a:pPr>
+                <a:r>
+                  <a:rPr lang="en-US" sz="800" dirty="0">
+                    <a:solidFill>
+                      <a:prstClr val="black"/>
+                    </a:solidFill>
+                  </a:rPr>
+                  <a:t>Us-west-1</a:t>
+                </a:r>
+                <a:endParaRPr kumimoji="0" lang="en-US" sz="800" b="0" i="0" u="none" strike="noStrike" kern="1200" cap="none" spc="0" normalizeH="0" baseline="0" noProof="0" dirty="0">
+                  <a:ln>
+                    <a:noFill/>
+                  </a:ln>
+                  <a:solidFill>
+                    <a:prstClr val="black"/>
+                  </a:solidFill>
+                  <a:effectLst/>
+                  <a:uLnTx/>
+                  <a:uFillTx/>
+                  <a:ea typeface="+mn-ea"/>
+                  <a:cs typeface="+mn-cs"/>
+                </a:endParaRPr>
+              </a:p>
+            </p:txBody>
+          </p:sp>
+          <p:sp>
+            <p:nvSpPr>
+              <p:cNvPr id="21" name="Arrow: Chevron 20">
+                <a:extLst>
+                  <a:ext uri="{FF2B5EF4-FFF2-40B4-BE49-F238E27FC236}">
+                    <a16:creationId xmlns:a16="http://schemas.microsoft.com/office/drawing/2014/main" id="{C60B1716-C9A4-F253-E974-95F1F394129E}"/>
+                  </a:ext>
+                </a:extLst>
+              </p:cNvPr>
+              <p:cNvSpPr/>
+              <p:nvPr/>
+            </p:nvSpPr>
+            <p:spPr>
+              <a:xfrm rot="5400000">
+                <a:off x="4026243" y="4166150"/>
+                <a:ext cx="351106" cy="466531"/>
+              </a:xfrm>
+              <a:prstGeom prst="chevron">
+                <a:avLst>
+                  <a:gd name="adj" fmla="val 14000"/>
+                </a:avLst>
+              </a:prstGeom>
+              <a:solidFill>
+                <a:schemeClr val="bg1"/>
+              </a:solidFill>
+              <a:ln w="12700">
+                <a:solidFill>
+                  <a:schemeClr val="tx1"/>
+                </a:solidFill>
+              </a:ln>
+            </p:spPr>
+            <p:style>
+              <a:lnRef idx="2">
+                <a:schemeClr val="accent1">
+                  <a:shade val="50000"/>
+                </a:schemeClr>
+              </a:lnRef>
+              <a:fillRef idx="1">
+                <a:schemeClr val="accent1"/>
+              </a:fillRef>
+              <a:effectRef idx="0">
+                <a:schemeClr val="accent1"/>
+              </a:effectRef>
+              <a:fontRef idx="minor">
+                <a:schemeClr val="lt1"/>
+              </a:fontRef>
+            </p:style>
+            <p:txBody>
+              <a:bodyPr tIns="0" rtlCol="0" anchor="t" anchorCtr="0"/>
+              <a:lstStyle/>
+              <a:p>
+                <a:pPr marL="0" marR="0" lvl="0" indent="0" algn="l" defTabSz="914400" rtl="0" eaLnBrk="1" fontAlgn="auto" latinLnBrk="0" hangingPunct="1">
+                  <a:lnSpc>
+                    <a:spcPct val="100000"/>
+                  </a:lnSpc>
+                  <a:spcBef>
+                    <a:spcPts val="0"/>
+                  </a:spcBef>
+                  <a:spcAft>
+                    <a:spcPts val="0"/>
+                  </a:spcAft>
+                  <a:buClrTx/>
+                  <a:buSzTx/>
+                  <a:buFontTx/>
+                  <a:buNone/>
+                  <a:tabLst/>
+                  <a:defRPr/>
+                </a:pPr>
+                <a:endParaRPr kumimoji="0" lang="en-US" sz="1000" b="0" i="0" u="none" strike="noStrike" kern="1200" cap="none" spc="0" normalizeH="0" baseline="0" noProof="0">
+                  <a:ln>
+                    <a:noFill/>
+                  </a:ln>
+                  <a:solidFill>
+                    <a:prstClr val="black"/>
+                  </a:solidFill>
+                  <a:effectLst/>
+                  <a:uLnTx/>
+                  <a:uFillTx/>
+                  <a:ea typeface="+mn-ea"/>
+                  <a:cs typeface="+mn-cs"/>
+                </a:endParaRPr>
+              </a:p>
+            </p:txBody>
+          </p:sp>
+          <p:sp>
+            <p:nvSpPr>
+              <p:cNvPr id="22" name="TextBox 21">
+                <a:extLst>
+                  <a:ext uri="{FF2B5EF4-FFF2-40B4-BE49-F238E27FC236}">
+                    <a16:creationId xmlns:a16="http://schemas.microsoft.com/office/drawing/2014/main" id="{F268AEC8-6C38-0232-0F56-5A4E5946BD1B}"/>
+                  </a:ext>
+                </a:extLst>
+              </p:cNvPr>
+              <p:cNvSpPr txBox="1"/>
+              <p:nvPr/>
+            </p:nvSpPr>
+            <p:spPr>
+              <a:xfrm>
+                <a:off x="3995650" y="4276305"/>
+                <a:ext cx="412292" cy="230832"/>
+              </a:xfrm>
+              <a:prstGeom prst="rect">
+                <a:avLst/>
+              </a:prstGeom>
+              <a:noFill/>
+            </p:spPr>
+            <p:txBody>
+              <a:bodyPr wrap="square" rtlCol="0">
+                <a:spAutoFit/>
+              </a:bodyPr>
+              <a:lstStyle/>
+              <a:p>
+                <a:pPr marL="0" marR="0" lvl="0" indent="0" algn="l" defTabSz="914400" rtl="0" eaLnBrk="1" fontAlgn="auto" latinLnBrk="0" hangingPunct="1">
+                  <a:lnSpc>
+                    <a:spcPct val="100000"/>
+                  </a:lnSpc>
+                  <a:spcBef>
+                    <a:spcPts val="0"/>
+                  </a:spcBef>
+                  <a:spcAft>
+                    <a:spcPts val="0"/>
+                  </a:spcAft>
+                  <a:buClrTx/>
+                  <a:buSzTx/>
+                  <a:buFontTx/>
+                  <a:buNone/>
+                  <a:tabLst/>
+                  <a:defRPr/>
+                </a:pPr>
+                <a:r>
+                  <a:rPr kumimoji="0" lang="en-US" sz="900" b="0" i="0" u="none" strike="noStrike" kern="1200" cap="none" spc="0" normalizeH="0" baseline="0" noProof="0" dirty="0">
+                    <a:ln>
+                      <a:noFill/>
+                    </a:ln>
+                    <a:solidFill>
+                      <a:prstClr val="black"/>
+                    </a:solidFill>
+                    <a:effectLst/>
+                    <a:uLnTx/>
+                    <a:uFillTx/>
+                    <a:ea typeface="+mn-ea"/>
+                    <a:cs typeface="+mn-cs"/>
+                  </a:rPr>
+                  <a:t>host</a:t>
+                </a:r>
+              </a:p>
+            </p:txBody>
+          </p:sp>
+        </p:grpSp>
+        <p:grpSp>
+          <p:nvGrpSpPr>
+            <p:cNvPr id="147" name="Group 146">
+              <a:extLst>
+                <a:ext uri="{FF2B5EF4-FFF2-40B4-BE49-F238E27FC236}">
+                  <a16:creationId xmlns:a16="http://schemas.microsoft.com/office/drawing/2014/main" id="{0375C6D9-01BE-B248-9FB8-0C3F014FEF4F}"/>
+                </a:ext>
+              </a:extLst>
+            </p:cNvPr>
+            <p:cNvGrpSpPr/>
+            <p:nvPr/>
+          </p:nvGrpSpPr>
+          <p:grpSpPr>
+            <a:xfrm>
+              <a:off x="5710290" y="3520515"/>
+              <a:ext cx="771421" cy="1177169"/>
+              <a:chOff x="4115528" y="2620040"/>
+              <a:chExt cx="771421" cy="1177169"/>
+            </a:xfrm>
+          </p:grpSpPr>
+          <p:grpSp>
+            <p:nvGrpSpPr>
+              <p:cNvPr id="146" name="Group 145">
+                <a:extLst>
+                  <a:ext uri="{FF2B5EF4-FFF2-40B4-BE49-F238E27FC236}">
+                    <a16:creationId xmlns:a16="http://schemas.microsoft.com/office/drawing/2014/main" id="{21372C5F-6019-6E0C-9508-4E8A358AF2EE}"/>
+                  </a:ext>
+                </a:extLst>
+              </p:cNvPr>
+              <p:cNvGrpSpPr/>
+              <p:nvPr/>
+            </p:nvGrpSpPr>
+            <p:grpSpPr>
+              <a:xfrm>
+                <a:off x="4115528" y="2823110"/>
+                <a:ext cx="771421" cy="815478"/>
+                <a:chOff x="4115528" y="2823110"/>
+                <a:chExt cx="771421" cy="815478"/>
+              </a:xfrm>
+            </p:grpSpPr>
+            <p:sp>
+              <p:nvSpPr>
+                <p:cNvPr id="34" name="Rectangle 33">
+                  <a:extLst>
+                    <a:ext uri="{FF2B5EF4-FFF2-40B4-BE49-F238E27FC236}">
+                      <a16:creationId xmlns:a16="http://schemas.microsoft.com/office/drawing/2014/main" id="{AC8C008F-40AE-7B56-066D-358A9B134B49}"/>
+                    </a:ext>
+                  </a:extLst>
+                </p:cNvPr>
+                <p:cNvSpPr/>
+                <p:nvPr/>
+              </p:nvSpPr>
+              <p:spPr>
+                <a:xfrm>
+                  <a:off x="4115528" y="3145212"/>
+                  <a:ext cx="771421" cy="279919"/>
+                </a:xfrm>
+                <a:prstGeom prst="rect">
+                  <a:avLst/>
+                </a:prstGeom>
+                <a:solidFill>
+                  <a:schemeClr val="bg1">
+                    <a:lumMod val="95000"/>
+                  </a:schemeClr>
+                </a:solidFill>
+                <a:ln w="19050">
+                  <a:solidFill>
+                    <a:schemeClr val="bg2"/>
+                  </a:solidFill>
+                </a:ln>
+              </p:spPr>
+              <p:style>
+                <a:lnRef idx="2">
+                  <a:schemeClr val="accent1">
+                    <a:shade val="50000"/>
+                  </a:schemeClr>
+                </a:lnRef>
+                <a:fillRef idx="1">
+                  <a:schemeClr val="accent1"/>
+                </a:fillRef>
+                <a:effectRef idx="0">
+                  <a:schemeClr val="accent1"/>
+                </a:effectRef>
+                <a:fontRef idx="minor">
+                  <a:schemeClr val="lt1"/>
+                </a:fontRef>
+              </p:style>
+              <p:txBody>
+                <a:bodyPr lIns="0" rIns="0" rtlCol="0" anchor="ctr"/>
+                <a:lstStyle/>
+                <a:p>
+                  <a:pPr marL="0" marR="0" lvl="0" indent="0" algn="ctr" defTabSz="914400" rtl="0" eaLnBrk="1" fontAlgn="auto" latinLnBrk="0" hangingPunct="1">
+                    <a:lnSpc>
+                      <a:spcPct val="100000"/>
+                    </a:lnSpc>
+                    <a:spcBef>
+                      <a:spcPts val="0"/>
+                    </a:spcBef>
+                    <a:spcAft>
+                      <a:spcPts val="0"/>
+                    </a:spcAft>
+                    <a:buClrTx/>
+                    <a:buSzTx/>
+                    <a:buFontTx/>
+                    <a:buNone/>
+                    <a:tabLst/>
+                    <a:defRPr/>
+                  </a:pPr>
+                  <a:r>
+                    <a:rPr kumimoji="0" lang="en-US" sz="900" b="0" i="0" u="none" strike="noStrike" kern="1200" cap="none" spc="0" normalizeH="0" baseline="0" noProof="0" dirty="0">
+                      <a:ln>
+                        <a:noFill/>
+                      </a:ln>
+                      <a:solidFill>
+                        <a:prstClr val="black"/>
+                      </a:solidFill>
+                      <a:effectLst/>
+                      <a:uLnTx/>
+                      <a:uFillTx/>
+                      <a:ea typeface="+mn-ea"/>
+                      <a:cs typeface="+mn-cs"/>
+                    </a:rPr>
+                    <a:t>Container Platform</a:t>
+                  </a:r>
+                </a:p>
+              </p:txBody>
+            </p:sp>
+            <p:sp>
+              <p:nvSpPr>
+                <p:cNvPr id="35" name="Rectangle: Rounded Corners 34">
+                  <a:extLst>
+                    <a:ext uri="{FF2B5EF4-FFF2-40B4-BE49-F238E27FC236}">
+                      <a16:creationId xmlns:a16="http://schemas.microsoft.com/office/drawing/2014/main" id="{DFBFC135-6FE4-4904-9572-E0043D70EBD6}"/>
+                    </a:ext>
+                  </a:extLst>
+                </p:cNvPr>
+                <p:cNvSpPr/>
+                <p:nvPr/>
+              </p:nvSpPr>
+              <p:spPr>
+                <a:xfrm>
+                  <a:off x="4115528" y="2823110"/>
+                  <a:ext cx="771420" cy="815478"/>
+                </a:xfrm>
+                <a:prstGeom prst="roundRect">
+                  <a:avLst/>
+                </a:prstGeom>
+                <a:noFill/>
+                <a:ln w="19050">
+                  <a:solidFill>
+                    <a:schemeClr val="tx1"/>
+                  </a:solidFill>
+                </a:ln>
+              </p:spPr>
+              <p:style>
+                <a:lnRef idx="2">
+                  <a:schemeClr val="accent1">
+                    <a:shade val="50000"/>
+                  </a:schemeClr>
+                </a:lnRef>
+                <a:fillRef idx="1">
+                  <a:schemeClr val="accent1"/>
+                </a:fillRef>
+                <a:effectRef idx="0">
+                  <a:schemeClr val="accent1"/>
+                </a:effectRef>
+                <a:fontRef idx="minor">
+                  <a:schemeClr val="lt1"/>
+                </a:fontRef>
+              </p:style>
+              <p:txBody>
+                <a:bodyPr lIns="45720" tIns="118872" rtlCol="0" anchor="t" anchorCtr="0"/>
+                <a:lstStyle/>
+                <a:p>
+                  <a:pPr marL="0" marR="0" lvl="0" indent="0" algn="l" defTabSz="914400" rtl="0" eaLnBrk="1" fontAlgn="auto" latinLnBrk="0" hangingPunct="1">
+                    <a:lnSpc>
+                      <a:spcPct val="100000"/>
+                    </a:lnSpc>
+                    <a:spcBef>
+                      <a:spcPts val="0"/>
+                    </a:spcBef>
+                    <a:spcAft>
+                      <a:spcPts val="0"/>
+                    </a:spcAft>
+                    <a:buClrTx/>
+                    <a:buSzTx/>
+                    <a:buFontTx/>
+                    <a:buNone/>
+                    <a:tabLst/>
+                    <a:defRPr/>
+                  </a:pPr>
+                  <a:r>
+                    <a:rPr lang="en-US" sz="800" dirty="0">
+                      <a:solidFill>
+                        <a:prstClr val="black"/>
+                      </a:solidFill>
+                    </a:rPr>
+                    <a:t>cluster-1</a:t>
+                  </a:r>
+                  <a:endParaRPr kumimoji="0" lang="en-US" sz="800" b="0" i="0" u="none" strike="noStrike" kern="1200" cap="none" spc="0" normalizeH="0" baseline="0" noProof="0" dirty="0">
+                    <a:ln>
+                      <a:noFill/>
+                    </a:ln>
+                    <a:solidFill>
+                      <a:prstClr val="black"/>
+                    </a:solidFill>
+                    <a:effectLst/>
+                    <a:uLnTx/>
+                    <a:uFillTx/>
+                    <a:ea typeface="+mn-ea"/>
+                    <a:cs typeface="+mn-cs"/>
+                  </a:endParaRPr>
+                </a:p>
+              </p:txBody>
+            </p:sp>
+          </p:grpSp>
+          <p:sp>
+            <p:nvSpPr>
+              <p:cNvPr id="36" name="Flowchart: Off-page Connector 35">
+                <a:extLst>
+                  <a:ext uri="{FF2B5EF4-FFF2-40B4-BE49-F238E27FC236}">
+                    <a16:creationId xmlns:a16="http://schemas.microsoft.com/office/drawing/2014/main" id="{200F0872-23D3-5A7D-8660-9DA58F7CD82D}"/>
+                  </a:ext>
+                </a:extLst>
+              </p:cNvPr>
+              <p:cNvSpPr/>
+              <p:nvPr/>
+            </p:nvSpPr>
+            <p:spPr>
+              <a:xfrm>
+                <a:off x="4267973" y="3517290"/>
+                <a:ext cx="466531" cy="279919"/>
+              </a:xfrm>
+              <a:prstGeom prst="flowChartOffpageConnector">
+                <a:avLst/>
+              </a:prstGeom>
+              <a:solidFill>
+                <a:schemeClr val="bg1"/>
+              </a:solidFill>
+              <a:ln w="19050">
+                <a:solidFill>
+                  <a:schemeClr val="tx1"/>
+                </a:solidFill>
+              </a:ln>
+            </p:spPr>
+            <p:style>
+              <a:lnRef idx="2">
+                <a:schemeClr val="accent1">
+                  <a:shade val="50000"/>
+                </a:schemeClr>
+              </a:lnRef>
+              <a:fillRef idx="1">
+                <a:schemeClr val="accent1"/>
+              </a:fillRef>
+              <a:effectRef idx="0">
+                <a:schemeClr val="accent1"/>
+              </a:effectRef>
+              <a:fontRef idx="minor">
+                <a:schemeClr val="lt1"/>
+              </a:fontRef>
+            </p:style>
+            <p:txBody>
+              <a:bodyPr tIns="0" rtlCol="0" anchor="t" anchorCtr="0"/>
+              <a:lstStyle/>
+              <a:p>
+                <a:pPr marL="0" marR="0" lvl="0" indent="0" algn="l" defTabSz="914400" rtl="0" eaLnBrk="1" fontAlgn="auto" latinLnBrk="0" hangingPunct="1">
+                  <a:lnSpc>
+                    <a:spcPct val="100000"/>
+                  </a:lnSpc>
+                  <a:spcBef>
+                    <a:spcPts val="0"/>
+                  </a:spcBef>
+                  <a:spcAft>
+                    <a:spcPts val="0"/>
+                  </a:spcAft>
+                  <a:buClrTx/>
+                  <a:buSzTx/>
+                  <a:buFontTx/>
+                  <a:buNone/>
+                  <a:tabLst/>
+                  <a:defRPr/>
+                </a:pPr>
+                <a:endParaRPr kumimoji="0" lang="en-US" sz="1000" b="0" i="0" u="none" strike="noStrike" kern="1200" cap="none" spc="0" normalizeH="0" baseline="0" noProof="0">
+                  <a:ln>
+                    <a:noFill/>
+                  </a:ln>
+                  <a:solidFill>
+                    <a:prstClr val="black"/>
+                  </a:solidFill>
+                  <a:effectLst/>
+                  <a:uLnTx/>
+                  <a:uFillTx/>
+                  <a:ea typeface="+mn-ea"/>
+                  <a:cs typeface="+mn-cs"/>
+                </a:endParaRPr>
+              </a:p>
+            </p:txBody>
+          </p:sp>
+          <p:sp>
+            <p:nvSpPr>
+              <p:cNvPr id="37" name="TextBox 36">
+                <a:extLst>
+                  <a:ext uri="{FF2B5EF4-FFF2-40B4-BE49-F238E27FC236}">
+                    <a16:creationId xmlns:a16="http://schemas.microsoft.com/office/drawing/2014/main" id="{75E9CD42-DACD-5EDE-FB72-AF6D27C6718E}"/>
+                  </a:ext>
+                </a:extLst>
+              </p:cNvPr>
+              <p:cNvSpPr txBox="1"/>
+              <p:nvPr/>
+            </p:nvSpPr>
+            <p:spPr>
+              <a:xfrm>
+                <a:off x="4295092" y="3534139"/>
+                <a:ext cx="412292" cy="230832"/>
+              </a:xfrm>
+              <a:prstGeom prst="rect">
+                <a:avLst/>
+              </a:prstGeom>
+              <a:noFill/>
+            </p:spPr>
+            <p:txBody>
+              <a:bodyPr wrap="square" rtlCol="0">
+                <a:spAutoFit/>
+              </a:bodyPr>
+              <a:lstStyle/>
+              <a:p>
+                <a:pPr marL="0" marR="0" lvl="0" indent="0" algn="l" defTabSz="914400" rtl="0" eaLnBrk="1" fontAlgn="auto" latinLnBrk="0" hangingPunct="1">
+                  <a:lnSpc>
+                    <a:spcPct val="100000"/>
+                  </a:lnSpc>
+                  <a:spcBef>
+                    <a:spcPts val="0"/>
+                  </a:spcBef>
+                  <a:spcAft>
+                    <a:spcPts val="0"/>
+                  </a:spcAft>
+                  <a:buClrTx/>
+                  <a:buSzTx/>
+                  <a:buFontTx/>
+                  <a:buNone/>
+                  <a:tabLst/>
+                  <a:defRPr/>
+                </a:pPr>
+                <a:r>
+                  <a:rPr kumimoji="0" lang="en-US" sz="900" b="0" i="0" u="none" strike="noStrike" kern="1200" cap="none" spc="0" normalizeH="0" baseline="0" noProof="0" dirty="0">
+                    <a:ln>
+                      <a:noFill/>
+                    </a:ln>
+                    <a:solidFill>
+                      <a:prstClr val="black"/>
+                    </a:solidFill>
+                    <a:effectLst/>
+                    <a:uLnTx/>
+                    <a:uFillTx/>
+                    <a:ea typeface="+mn-ea"/>
+                    <a:cs typeface="+mn-cs"/>
+                  </a:rPr>
+                  <a:t>host</a:t>
+                </a:r>
+              </a:p>
+            </p:txBody>
+          </p:sp>
+          <p:grpSp>
+            <p:nvGrpSpPr>
+              <p:cNvPr id="58" name="Group 57">
+                <a:extLst>
+                  <a:ext uri="{FF2B5EF4-FFF2-40B4-BE49-F238E27FC236}">
+                    <a16:creationId xmlns:a16="http://schemas.microsoft.com/office/drawing/2014/main" id="{F6FF56A3-16B1-831C-57CE-9919876BB236}"/>
+                  </a:ext>
+                </a:extLst>
+              </p:cNvPr>
+              <p:cNvGrpSpPr/>
+              <p:nvPr/>
+            </p:nvGrpSpPr>
+            <p:grpSpPr>
+              <a:xfrm>
+                <a:off x="4267973" y="2620040"/>
+                <a:ext cx="466531" cy="351106"/>
+                <a:chOff x="6810318" y="4284899"/>
+                <a:chExt cx="466531" cy="351106"/>
+              </a:xfrm>
+            </p:grpSpPr>
+            <p:sp>
+              <p:nvSpPr>
+                <p:cNvPr id="54" name="Arrow: Chevron 53">
+                  <a:extLst>
+                    <a:ext uri="{FF2B5EF4-FFF2-40B4-BE49-F238E27FC236}">
+                      <a16:creationId xmlns:a16="http://schemas.microsoft.com/office/drawing/2014/main" id="{20E00F62-D32A-8FB7-5FEB-5D3162EC33D3}"/>
+                    </a:ext>
+                  </a:extLst>
+                </p:cNvPr>
+                <p:cNvSpPr/>
+                <p:nvPr/>
+              </p:nvSpPr>
+              <p:spPr>
+                <a:xfrm rot="5400000">
+                  <a:off x="6868031" y="4227186"/>
+                  <a:ext cx="351106" cy="466531"/>
+                </a:xfrm>
+                <a:prstGeom prst="chevron">
+                  <a:avLst>
+                    <a:gd name="adj" fmla="val 14000"/>
+                  </a:avLst>
+                </a:prstGeom>
+                <a:solidFill>
+                  <a:schemeClr val="bg1"/>
+                </a:solidFill>
+                <a:ln w="12700">
+                  <a:solidFill>
+                    <a:schemeClr val="tx1"/>
+                  </a:solidFill>
+                </a:ln>
+              </p:spPr>
+              <p:style>
+                <a:lnRef idx="2">
+                  <a:schemeClr val="accent1">
+                    <a:shade val="50000"/>
+                  </a:schemeClr>
+                </a:lnRef>
+                <a:fillRef idx="1">
+                  <a:schemeClr val="accent1"/>
+                </a:fillRef>
+                <a:effectRef idx="0">
+                  <a:schemeClr val="accent1"/>
+                </a:effectRef>
+                <a:fontRef idx="minor">
+                  <a:schemeClr val="lt1"/>
+                </a:fontRef>
+              </p:style>
+              <p:txBody>
+                <a:bodyPr tIns="0" rtlCol="0" anchor="t" anchorCtr="0"/>
+                <a:lstStyle/>
+                <a:p>
+                  <a:pPr marL="0" marR="0" lvl="0" indent="0" algn="l" defTabSz="914400" rtl="0" eaLnBrk="1" fontAlgn="auto" latinLnBrk="0" hangingPunct="1">
+                    <a:lnSpc>
+                      <a:spcPct val="100000"/>
+                    </a:lnSpc>
+                    <a:spcBef>
+                      <a:spcPts val="0"/>
+                    </a:spcBef>
+                    <a:spcAft>
+                      <a:spcPts val="0"/>
+                    </a:spcAft>
+                    <a:buClrTx/>
+                    <a:buSzTx/>
+                    <a:buFontTx/>
+                    <a:buNone/>
+                    <a:tabLst/>
+                    <a:defRPr/>
+                  </a:pPr>
+                  <a:endParaRPr kumimoji="0" lang="en-US" sz="1000" b="0" i="0" u="none" strike="noStrike" kern="1200" cap="none" spc="0" normalizeH="0" baseline="0" noProof="0">
+                    <a:ln>
+                      <a:noFill/>
+                    </a:ln>
+                    <a:solidFill>
+                      <a:prstClr val="black"/>
+                    </a:solidFill>
+                    <a:effectLst/>
+                    <a:uLnTx/>
+                    <a:uFillTx/>
+                    <a:ea typeface="+mn-ea"/>
+                    <a:cs typeface="+mn-cs"/>
+                  </a:endParaRPr>
+                </a:p>
+              </p:txBody>
+            </p:sp>
+            <p:sp>
+              <p:nvSpPr>
+                <p:cNvPr id="57" name="TextBox 56">
+                  <a:extLst>
+                    <a:ext uri="{FF2B5EF4-FFF2-40B4-BE49-F238E27FC236}">
+                      <a16:creationId xmlns:a16="http://schemas.microsoft.com/office/drawing/2014/main" id="{430F5921-AE55-FC29-BAE4-5A0B0592787C}"/>
+                    </a:ext>
+                  </a:extLst>
+                </p:cNvPr>
+                <p:cNvSpPr txBox="1"/>
+                <p:nvPr/>
+              </p:nvSpPr>
+              <p:spPr>
+                <a:xfrm>
+                  <a:off x="6837438" y="4337341"/>
+                  <a:ext cx="412292" cy="230832"/>
+                </a:xfrm>
+                <a:prstGeom prst="rect">
+                  <a:avLst/>
+                </a:prstGeom>
+                <a:noFill/>
+              </p:spPr>
+              <p:txBody>
+                <a:bodyPr wrap="square" rtlCol="0">
+                  <a:spAutoFit/>
+                </a:bodyPr>
+                <a:lstStyle/>
+                <a:p>
+                  <a:pPr marL="0" marR="0" lvl="0" indent="0" algn="l" defTabSz="914400" rtl="0" eaLnBrk="1" fontAlgn="auto" latinLnBrk="0" hangingPunct="1">
+                    <a:lnSpc>
+                      <a:spcPct val="100000"/>
+                    </a:lnSpc>
+                    <a:spcBef>
+                      <a:spcPts val="0"/>
+                    </a:spcBef>
+                    <a:spcAft>
+                      <a:spcPts val="0"/>
+                    </a:spcAft>
+                    <a:buClrTx/>
+                    <a:buSzTx/>
+                    <a:buFontTx/>
+                    <a:buNone/>
+                    <a:tabLst/>
+                    <a:defRPr/>
+                  </a:pPr>
+                  <a:r>
+                    <a:rPr kumimoji="0" lang="en-US" sz="900" b="0" i="0" u="none" strike="noStrike" kern="1200" cap="none" spc="0" normalizeH="0" baseline="0" noProof="0" dirty="0">
+                      <a:ln>
+                        <a:noFill/>
+                      </a:ln>
+                      <a:solidFill>
+                        <a:prstClr val="black"/>
+                      </a:solidFill>
+                      <a:effectLst/>
+                      <a:uLnTx/>
+                      <a:uFillTx/>
+                      <a:ea typeface="+mn-ea"/>
+                      <a:cs typeface="+mn-cs"/>
+                    </a:rPr>
+                    <a:t>host</a:t>
+                  </a:r>
+                </a:p>
+              </p:txBody>
+            </p:sp>
+          </p:grpSp>
+        </p:grpSp>
+        <p:cxnSp>
+          <p:nvCxnSpPr>
+            <p:cNvPr id="17" name="Straight Arrow Connector 16">
+              <a:extLst>
+                <a:ext uri="{FF2B5EF4-FFF2-40B4-BE49-F238E27FC236}">
+                  <a16:creationId xmlns:a16="http://schemas.microsoft.com/office/drawing/2014/main" id="{E58D11E9-E884-B98D-C7B8-50308964A9BB}"/>
+                </a:ext>
+              </a:extLst>
+            </p:cNvPr>
+            <p:cNvCxnSpPr>
+              <a:cxnSpLocks/>
+            </p:cNvCxnSpPr>
+            <p:nvPr/>
+          </p:nvCxnSpPr>
+          <p:spPr>
+            <a:xfrm flipH="1" flipV="1">
+              <a:off x="6092198" y="4682352"/>
+              <a:ext cx="760" cy="261501"/>
+            </a:xfrm>
+            <a:prstGeom prst="straightConnector1">
+              <a:avLst/>
+            </a:prstGeom>
+            <a:ln w="12700">
+              <a:solidFill>
+                <a:schemeClr val="tx1"/>
+              </a:solidFill>
+              <a:headEnd type="triangle" w="med" len="med"/>
+              <a:tailEnd type="none" w="med" len="med"/>
+            </a:ln>
+          </p:spPr>
+          <p:style>
+            <a:lnRef idx="1">
+              <a:schemeClr val="accent1"/>
+            </a:lnRef>
+            <a:fillRef idx="0">
+              <a:schemeClr val="accent1"/>
+            </a:fillRef>
+            <a:effectRef idx="0">
+              <a:schemeClr val="accent1"/>
+            </a:effectRef>
+            <a:fontRef idx="minor">
+              <a:schemeClr val="tx1"/>
+            </a:fontRef>
+          </p:style>
+        </p:cxnSp>
+      </p:grpSp>
+    </p:spTree>
+    <p:extLst>
+      <p:ext uri="{BB962C8B-B14F-4D97-AF65-F5344CB8AC3E}">
+        <p14:creationId xmlns:p14="http://schemas.microsoft.com/office/powerpoint/2010/main" val="3898307334"/>
       </p:ext>
     </p:extLst>
   </p:cSld>

</xml_diff>

<commit_message>
Document Managed Kubernetes Cluster deployment scenario (#296)
</commit_message>
<xml_diff>
--- a/profiles/community/tosca/abstract/platform/images/sources/platforms.pptx
+++ b/profiles/community/tosca/abstract/platform/images/sources/platforms.pptx
@@ -14,6 +14,7 @@
     <p:sldId id="282" r:id="rId8"/>
     <p:sldId id="281" r:id="rId9"/>
     <p:sldId id="277" r:id="rId10"/>
+    <p:sldId id="283" r:id="rId11"/>
   </p:sldIdLst>
   <p:sldSz cx="12192000" cy="6858000"/>
   <p:notesSz cx="6858000" cy="9144000"/>
@@ -267,7 +268,7 @@
           <a:p>
             <a:fld id="{5BAF7096-B8B4-4A3B-8A26-165AAEF12400}" type="datetimeFigureOut">
               <a:rPr lang="en-US" smtClean="0"/>
-              <a:t>3/31/2026</a:t>
+              <a:t>4/7/2026</a:t>
             </a:fld>
             <a:endParaRPr lang="en-US"/>
           </a:p>
@@ -465,7 +466,7 @@
           <a:p>
             <a:fld id="{5BAF7096-B8B4-4A3B-8A26-165AAEF12400}" type="datetimeFigureOut">
               <a:rPr lang="en-US" smtClean="0"/>
-              <a:t>3/31/2026</a:t>
+              <a:t>4/7/2026</a:t>
             </a:fld>
             <a:endParaRPr lang="en-US"/>
           </a:p>
@@ -673,7 +674,7 @@
           <a:p>
             <a:fld id="{5BAF7096-B8B4-4A3B-8A26-165AAEF12400}" type="datetimeFigureOut">
               <a:rPr lang="en-US" smtClean="0"/>
-              <a:t>3/31/2026</a:t>
+              <a:t>4/7/2026</a:t>
             </a:fld>
             <a:endParaRPr lang="en-US"/>
           </a:p>
@@ -871,7 +872,7 @@
           <a:p>
             <a:fld id="{5BAF7096-B8B4-4A3B-8A26-165AAEF12400}" type="datetimeFigureOut">
               <a:rPr lang="en-US" smtClean="0"/>
-              <a:t>3/31/2026</a:t>
+              <a:t>4/7/2026</a:t>
             </a:fld>
             <a:endParaRPr lang="en-US"/>
           </a:p>
@@ -1146,7 +1147,7 @@
           <a:p>
             <a:fld id="{5BAF7096-B8B4-4A3B-8A26-165AAEF12400}" type="datetimeFigureOut">
               <a:rPr lang="en-US" smtClean="0"/>
-              <a:t>3/31/2026</a:t>
+              <a:t>4/7/2026</a:t>
             </a:fld>
             <a:endParaRPr lang="en-US"/>
           </a:p>
@@ -1411,7 +1412,7 @@
           <a:p>
             <a:fld id="{5BAF7096-B8B4-4A3B-8A26-165AAEF12400}" type="datetimeFigureOut">
               <a:rPr lang="en-US" smtClean="0"/>
-              <a:t>3/31/2026</a:t>
+              <a:t>4/7/2026</a:t>
             </a:fld>
             <a:endParaRPr lang="en-US"/>
           </a:p>
@@ -1823,7 +1824,7 @@
           <a:p>
             <a:fld id="{5BAF7096-B8B4-4A3B-8A26-165AAEF12400}" type="datetimeFigureOut">
               <a:rPr lang="en-US" smtClean="0"/>
-              <a:t>3/31/2026</a:t>
+              <a:t>4/7/2026</a:t>
             </a:fld>
             <a:endParaRPr lang="en-US"/>
           </a:p>
@@ -1964,7 +1965,7 @@
           <a:p>
             <a:fld id="{5BAF7096-B8B4-4A3B-8A26-165AAEF12400}" type="datetimeFigureOut">
               <a:rPr lang="en-US" smtClean="0"/>
-              <a:t>3/31/2026</a:t>
+              <a:t>4/7/2026</a:t>
             </a:fld>
             <a:endParaRPr lang="en-US"/>
           </a:p>
@@ -2077,7 +2078,7 @@
           <a:p>
             <a:fld id="{5BAF7096-B8B4-4A3B-8A26-165AAEF12400}" type="datetimeFigureOut">
               <a:rPr lang="en-US" smtClean="0"/>
-              <a:t>3/31/2026</a:t>
+              <a:t>4/7/2026</a:t>
             </a:fld>
             <a:endParaRPr lang="en-US"/>
           </a:p>
@@ -2388,7 +2389,7 @@
           <a:p>
             <a:fld id="{5BAF7096-B8B4-4A3B-8A26-165AAEF12400}" type="datetimeFigureOut">
               <a:rPr lang="en-US" smtClean="0"/>
-              <a:t>3/31/2026</a:t>
+              <a:t>4/7/2026</a:t>
             </a:fld>
             <a:endParaRPr lang="en-US"/>
           </a:p>
@@ -2676,7 +2677,7 @@
           <a:p>
             <a:fld id="{5BAF7096-B8B4-4A3B-8A26-165AAEF12400}" type="datetimeFigureOut">
               <a:rPr lang="en-US" smtClean="0"/>
-              <a:t>3/31/2026</a:t>
+              <a:t>4/7/2026</a:t>
             </a:fld>
             <a:endParaRPr lang="en-US"/>
           </a:p>
@@ -2917,7 +2918,7 @@
           <a:p>
             <a:fld id="{5BAF7096-B8B4-4A3B-8A26-165AAEF12400}" type="datetimeFigureOut">
               <a:rPr lang="en-US" smtClean="0"/>
-              <a:t>3/31/2026</a:t>
+              <a:t>4/7/2026</a:t>
             </a:fld>
             <a:endParaRPr lang="en-US"/>
           </a:p>
@@ -3758,6 +3759,999 @@
     <p:extLst>
       <p:ext uri="{BB962C8B-B14F-4D97-AF65-F5344CB8AC3E}">
         <p14:creationId xmlns:p14="http://schemas.microsoft.com/office/powerpoint/2010/main" val="1160173518"/>
+      </p:ext>
+    </p:extLst>
+  </p:cSld>
+  <p:clrMapOvr>
+    <a:masterClrMapping/>
+  </p:clrMapOvr>
+</p:sld>
+</file>
+
+<file path=ppt/slides/slide10.xml><?xml version="1.0" encoding="utf-8"?>
+<p:sld xmlns:a="http://schemas.openxmlformats.org/drawingml/2006/main" xmlns:r="http://schemas.openxmlformats.org/officeDocument/2006/relationships" xmlns:p="http://schemas.openxmlformats.org/presentationml/2006/main">
+  <p:cSld>
+    <p:spTree>
+      <p:nvGrpSpPr>
+        <p:cNvPr id="1" name=""/>
+        <p:cNvGrpSpPr/>
+        <p:nvPr/>
+      </p:nvGrpSpPr>
+      <p:grpSpPr>
+        <a:xfrm>
+          <a:off x="0" y="0"/>
+          <a:ext cx="0" cy="0"/>
+          <a:chOff x="0" y="0"/>
+          <a:chExt cx="0" cy="0"/>
+        </a:xfrm>
+      </p:grpSpPr>
+      <p:grpSp>
+        <p:nvGrpSpPr>
+          <p:cNvPr id="2" name="Group 1">
+            <a:extLst>
+              <a:ext uri="{FF2B5EF4-FFF2-40B4-BE49-F238E27FC236}">
+                <a16:creationId xmlns:a16="http://schemas.microsoft.com/office/drawing/2014/main" id="{8165D0B7-B119-73EE-16D6-BE83092F115C}"/>
+              </a:ext>
+            </a:extLst>
+          </p:cNvPr>
+          <p:cNvGrpSpPr/>
+          <p:nvPr/>
+        </p:nvGrpSpPr>
+        <p:grpSpPr>
+          <a:xfrm>
+            <a:off x="5710290" y="2244919"/>
+            <a:ext cx="771421" cy="2368163"/>
+            <a:chOff x="5710290" y="3520515"/>
+            <a:chExt cx="771421" cy="2368163"/>
+          </a:xfrm>
+        </p:grpSpPr>
+        <p:grpSp>
+          <p:nvGrpSpPr>
+            <p:cNvPr id="18" name="Group 17">
+              <a:extLst>
+                <a:ext uri="{FF2B5EF4-FFF2-40B4-BE49-F238E27FC236}">
+                  <a16:creationId xmlns:a16="http://schemas.microsoft.com/office/drawing/2014/main" id="{0965E86A-1C94-A558-145A-CBC2E89E62AD}"/>
+                </a:ext>
+              </a:extLst>
+            </p:cNvPr>
+            <p:cNvGrpSpPr/>
+            <p:nvPr/>
+          </p:nvGrpSpPr>
+          <p:grpSpPr>
+            <a:xfrm>
+              <a:off x="5710290" y="4897646"/>
+              <a:ext cx="771421" cy="991032"/>
+              <a:chOff x="3816079" y="4223863"/>
+              <a:chExt cx="771421" cy="991032"/>
+            </a:xfrm>
+          </p:grpSpPr>
+          <p:sp>
+            <p:nvSpPr>
+              <p:cNvPr id="19" name="Rectangle 18">
+                <a:extLst>
+                  <a:ext uri="{FF2B5EF4-FFF2-40B4-BE49-F238E27FC236}">
+                    <a16:creationId xmlns:a16="http://schemas.microsoft.com/office/drawing/2014/main" id="{D1423ABE-B95A-39BF-B25A-51AE295D7BCC}"/>
+                  </a:ext>
+                </a:extLst>
+              </p:cNvPr>
+              <p:cNvSpPr/>
+              <p:nvPr/>
+            </p:nvSpPr>
+            <p:spPr>
+              <a:xfrm>
+                <a:off x="3816079" y="4722603"/>
+                <a:ext cx="771421" cy="250978"/>
+              </a:xfrm>
+              <a:prstGeom prst="rect">
+                <a:avLst/>
+              </a:prstGeom>
+              <a:solidFill>
+                <a:schemeClr val="bg1">
+                  <a:lumMod val="95000"/>
+                </a:schemeClr>
+              </a:solidFill>
+              <a:ln w="19050">
+                <a:solidFill>
+                  <a:schemeClr val="bg2"/>
+                </a:solidFill>
+              </a:ln>
+            </p:spPr>
+            <p:style>
+              <a:lnRef idx="2">
+                <a:schemeClr val="accent1">
+                  <a:shade val="50000"/>
+                </a:schemeClr>
+              </a:lnRef>
+              <a:fillRef idx="1">
+                <a:schemeClr val="accent1"/>
+              </a:fillRef>
+              <a:effectRef idx="0">
+                <a:schemeClr val="accent1"/>
+              </a:effectRef>
+              <a:fontRef idx="minor">
+                <a:schemeClr val="lt1"/>
+              </a:fontRef>
+            </p:style>
+            <p:txBody>
+              <a:bodyPr lIns="0" rIns="0" rtlCol="0" anchor="ctr"/>
+              <a:lstStyle/>
+              <a:p>
+                <a:pPr marL="0" marR="0" lvl="0" indent="0" algn="ctr" defTabSz="914400" rtl="0" eaLnBrk="1" fontAlgn="auto" latinLnBrk="0" hangingPunct="1">
+                  <a:lnSpc>
+                    <a:spcPct val="100000"/>
+                  </a:lnSpc>
+                  <a:spcBef>
+                    <a:spcPts val="0"/>
+                  </a:spcBef>
+                  <a:spcAft>
+                    <a:spcPts val="0"/>
+                  </a:spcAft>
+                  <a:buClrTx/>
+                  <a:buSzTx/>
+                  <a:buFontTx/>
+                  <a:buNone/>
+                  <a:tabLst/>
+                  <a:defRPr/>
+                </a:pPr>
+                <a:r>
+                  <a:rPr kumimoji="0" lang="en-US" sz="900" b="0" i="0" u="none" strike="noStrike" kern="1200" cap="none" spc="0" normalizeH="0" baseline="0" noProof="0" dirty="0">
+                    <a:ln>
+                      <a:noFill/>
+                    </a:ln>
+                    <a:solidFill>
+                      <a:prstClr val="black"/>
+                    </a:solidFill>
+                    <a:effectLst/>
+                    <a:uLnTx/>
+                    <a:uFillTx/>
+                    <a:ea typeface="+mn-ea"/>
+                    <a:cs typeface="+mn-cs"/>
+                  </a:rPr>
+                  <a:t>Virtualization</a:t>
+                </a:r>
+              </a:p>
+              <a:p>
+                <a:pPr marL="0" marR="0" lvl="0" indent="0" algn="ctr" defTabSz="914400" rtl="0" eaLnBrk="1" fontAlgn="auto" latinLnBrk="0" hangingPunct="1">
+                  <a:lnSpc>
+                    <a:spcPct val="100000"/>
+                  </a:lnSpc>
+                  <a:spcBef>
+                    <a:spcPts val="0"/>
+                  </a:spcBef>
+                  <a:spcAft>
+                    <a:spcPts val="0"/>
+                  </a:spcAft>
+                  <a:buClrTx/>
+                  <a:buSzTx/>
+                  <a:buFontTx/>
+                  <a:buNone/>
+                  <a:tabLst/>
+                  <a:defRPr/>
+                </a:pPr>
+                <a:r>
+                  <a:rPr kumimoji="0" lang="en-US" sz="900" b="0" i="0" u="none" strike="noStrike" kern="1200" cap="none" spc="0" normalizeH="0" baseline="0" noProof="0" dirty="0">
+                    <a:ln>
+                      <a:noFill/>
+                    </a:ln>
+                    <a:solidFill>
+                      <a:prstClr val="black"/>
+                    </a:solidFill>
+                    <a:effectLst/>
+                    <a:uLnTx/>
+                    <a:uFillTx/>
+                    <a:ea typeface="+mn-ea"/>
+                    <a:cs typeface="+mn-cs"/>
+                  </a:rPr>
+                  <a:t>Platform</a:t>
+                </a:r>
+              </a:p>
+            </p:txBody>
+          </p:sp>
+          <p:sp>
+            <p:nvSpPr>
+              <p:cNvPr id="20" name="Rectangle: Rounded Corners 19">
+                <a:extLst>
+                  <a:ext uri="{FF2B5EF4-FFF2-40B4-BE49-F238E27FC236}">
+                    <a16:creationId xmlns:a16="http://schemas.microsoft.com/office/drawing/2014/main" id="{78CF353B-5D46-A40D-867F-63CF5553D636}"/>
+                  </a:ext>
+                </a:extLst>
+              </p:cNvPr>
+              <p:cNvSpPr/>
+              <p:nvPr/>
+            </p:nvSpPr>
+            <p:spPr>
+              <a:xfrm>
+                <a:off x="3816080" y="4399416"/>
+                <a:ext cx="771420" cy="815479"/>
+              </a:xfrm>
+              <a:prstGeom prst="roundRect">
+                <a:avLst/>
+              </a:prstGeom>
+              <a:noFill/>
+              <a:ln w="19050">
+                <a:solidFill>
+                  <a:schemeClr val="tx1"/>
+                </a:solidFill>
+              </a:ln>
+            </p:spPr>
+            <p:style>
+              <a:lnRef idx="2">
+                <a:schemeClr val="accent1">
+                  <a:shade val="50000"/>
+                </a:schemeClr>
+              </a:lnRef>
+              <a:fillRef idx="1">
+                <a:schemeClr val="accent1"/>
+              </a:fillRef>
+              <a:effectRef idx="0">
+                <a:schemeClr val="accent1"/>
+              </a:effectRef>
+              <a:fontRef idx="minor">
+                <a:schemeClr val="lt1"/>
+              </a:fontRef>
+            </p:style>
+            <p:txBody>
+              <a:bodyPr lIns="45720" tIns="0" bIns="9144" rtlCol="0" anchor="b" anchorCtr="0"/>
+              <a:lstStyle/>
+              <a:p>
+                <a:pPr lvl="0">
+                  <a:defRPr/>
+                </a:pPr>
+                <a:r>
+                  <a:rPr lang="en-US" sz="800" dirty="0">
+                    <a:solidFill>
+                      <a:prstClr val="black"/>
+                    </a:solidFill>
+                  </a:rPr>
+                  <a:t>Us-west-1</a:t>
+                </a:r>
+                <a:endParaRPr kumimoji="0" lang="en-US" sz="800" b="0" i="0" u="none" strike="noStrike" kern="1200" cap="none" spc="0" normalizeH="0" baseline="0" noProof="0" dirty="0">
+                  <a:ln>
+                    <a:noFill/>
+                  </a:ln>
+                  <a:solidFill>
+                    <a:prstClr val="black"/>
+                  </a:solidFill>
+                  <a:effectLst/>
+                  <a:uLnTx/>
+                  <a:uFillTx/>
+                  <a:ea typeface="+mn-ea"/>
+                  <a:cs typeface="+mn-cs"/>
+                </a:endParaRPr>
+              </a:p>
+            </p:txBody>
+          </p:sp>
+          <p:sp>
+            <p:nvSpPr>
+              <p:cNvPr id="21" name="Arrow: Chevron 20">
+                <a:extLst>
+                  <a:ext uri="{FF2B5EF4-FFF2-40B4-BE49-F238E27FC236}">
+                    <a16:creationId xmlns:a16="http://schemas.microsoft.com/office/drawing/2014/main" id="{C60B1716-C9A4-F253-E974-95F1F394129E}"/>
+                  </a:ext>
+                </a:extLst>
+              </p:cNvPr>
+              <p:cNvSpPr/>
+              <p:nvPr/>
+            </p:nvSpPr>
+            <p:spPr>
+              <a:xfrm rot="5400000">
+                <a:off x="4026243" y="4166150"/>
+                <a:ext cx="351106" cy="466531"/>
+              </a:xfrm>
+              <a:prstGeom prst="chevron">
+                <a:avLst>
+                  <a:gd name="adj" fmla="val 14000"/>
+                </a:avLst>
+              </a:prstGeom>
+              <a:solidFill>
+                <a:schemeClr val="bg1"/>
+              </a:solidFill>
+              <a:ln w="12700">
+                <a:solidFill>
+                  <a:schemeClr val="tx1"/>
+                </a:solidFill>
+              </a:ln>
+            </p:spPr>
+            <p:style>
+              <a:lnRef idx="2">
+                <a:schemeClr val="accent1">
+                  <a:shade val="50000"/>
+                </a:schemeClr>
+              </a:lnRef>
+              <a:fillRef idx="1">
+                <a:schemeClr val="accent1"/>
+              </a:fillRef>
+              <a:effectRef idx="0">
+                <a:schemeClr val="accent1"/>
+              </a:effectRef>
+              <a:fontRef idx="minor">
+                <a:schemeClr val="lt1"/>
+              </a:fontRef>
+            </p:style>
+            <p:txBody>
+              <a:bodyPr tIns="0" rtlCol="0" anchor="t" anchorCtr="0"/>
+              <a:lstStyle/>
+              <a:p>
+                <a:pPr marL="0" marR="0" lvl="0" indent="0" algn="l" defTabSz="914400" rtl="0" eaLnBrk="1" fontAlgn="auto" latinLnBrk="0" hangingPunct="1">
+                  <a:lnSpc>
+                    <a:spcPct val="100000"/>
+                  </a:lnSpc>
+                  <a:spcBef>
+                    <a:spcPts val="0"/>
+                  </a:spcBef>
+                  <a:spcAft>
+                    <a:spcPts val="0"/>
+                  </a:spcAft>
+                  <a:buClrTx/>
+                  <a:buSzTx/>
+                  <a:buFontTx/>
+                  <a:buNone/>
+                  <a:tabLst/>
+                  <a:defRPr/>
+                </a:pPr>
+                <a:endParaRPr kumimoji="0" lang="en-US" sz="1000" b="0" i="0" u="none" strike="noStrike" kern="1200" cap="none" spc="0" normalizeH="0" baseline="0" noProof="0">
+                  <a:ln>
+                    <a:noFill/>
+                  </a:ln>
+                  <a:solidFill>
+                    <a:prstClr val="black"/>
+                  </a:solidFill>
+                  <a:effectLst/>
+                  <a:uLnTx/>
+                  <a:uFillTx/>
+                  <a:ea typeface="+mn-ea"/>
+                  <a:cs typeface="+mn-cs"/>
+                </a:endParaRPr>
+              </a:p>
+            </p:txBody>
+          </p:sp>
+          <p:sp>
+            <p:nvSpPr>
+              <p:cNvPr id="22" name="TextBox 21">
+                <a:extLst>
+                  <a:ext uri="{FF2B5EF4-FFF2-40B4-BE49-F238E27FC236}">
+                    <a16:creationId xmlns:a16="http://schemas.microsoft.com/office/drawing/2014/main" id="{F268AEC8-6C38-0232-0F56-5A4E5946BD1B}"/>
+                  </a:ext>
+                </a:extLst>
+              </p:cNvPr>
+              <p:cNvSpPr txBox="1"/>
+              <p:nvPr/>
+            </p:nvSpPr>
+            <p:spPr>
+              <a:xfrm>
+                <a:off x="3995650" y="4276305"/>
+                <a:ext cx="412292" cy="230832"/>
+              </a:xfrm>
+              <a:prstGeom prst="rect">
+                <a:avLst/>
+              </a:prstGeom>
+              <a:noFill/>
+            </p:spPr>
+            <p:txBody>
+              <a:bodyPr wrap="square" rtlCol="0">
+                <a:spAutoFit/>
+              </a:bodyPr>
+              <a:lstStyle/>
+              <a:p>
+                <a:pPr marL="0" marR="0" lvl="0" indent="0" algn="l" defTabSz="914400" rtl="0" eaLnBrk="1" fontAlgn="auto" latinLnBrk="0" hangingPunct="1">
+                  <a:lnSpc>
+                    <a:spcPct val="100000"/>
+                  </a:lnSpc>
+                  <a:spcBef>
+                    <a:spcPts val="0"/>
+                  </a:spcBef>
+                  <a:spcAft>
+                    <a:spcPts val="0"/>
+                  </a:spcAft>
+                  <a:buClrTx/>
+                  <a:buSzTx/>
+                  <a:buFontTx/>
+                  <a:buNone/>
+                  <a:tabLst/>
+                  <a:defRPr/>
+                </a:pPr>
+                <a:r>
+                  <a:rPr kumimoji="0" lang="en-US" sz="900" b="0" i="0" u="none" strike="noStrike" kern="1200" cap="none" spc="0" normalizeH="0" baseline="0" noProof="0" dirty="0">
+                    <a:ln>
+                      <a:noFill/>
+                    </a:ln>
+                    <a:solidFill>
+                      <a:prstClr val="black"/>
+                    </a:solidFill>
+                    <a:effectLst/>
+                    <a:uLnTx/>
+                    <a:uFillTx/>
+                    <a:ea typeface="+mn-ea"/>
+                    <a:cs typeface="+mn-cs"/>
+                  </a:rPr>
+                  <a:t>host</a:t>
+                </a:r>
+              </a:p>
+            </p:txBody>
+          </p:sp>
+        </p:grpSp>
+        <p:grpSp>
+          <p:nvGrpSpPr>
+            <p:cNvPr id="147" name="Group 146">
+              <a:extLst>
+                <a:ext uri="{FF2B5EF4-FFF2-40B4-BE49-F238E27FC236}">
+                  <a16:creationId xmlns:a16="http://schemas.microsoft.com/office/drawing/2014/main" id="{0375C6D9-01BE-B248-9FB8-0C3F014FEF4F}"/>
+                </a:ext>
+              </a:extLst>
+            </p:cNvPr>
+            <p:cNvGrpSpPr/>
+            <p:nvPr/>
+          </p:nvGrpSpPr>
+          <p:grpSpPr>
+            <a:xfrm>
+              <a:off x="5710290" y="3520515"/>
+              <a:ext cx="771421" cy="1177169"/>
+              <a:chOff x="4115528" y="2620040"/>
+              <a:chExt cx="771421" cy="1177169"/>
+            </a:xfrm>
+          </p:grpSpPr>
+          <p:grpSp>
+            <p:nvGrpSpPr>
+              <p:cNvPr id="146" name="Group 145">
+                <a:extLst>
+                  <a:ext uri="{FF2B5EF4-FFF2-40B4-BE49-F238E27FC236}">
+                    <a16:creationId xmlns:a16="http://schemas.microsoft.com/office/drawing/2014/main" id="{21372C5F-6019-6E0C-9508-4E8A358AF2EE}"/>
+                  </a:ext>
+                </a:extLst>
+              </p:cNvPr>
+              <p:cNvGrpSpPr/>
+              <p:nvPr/>
+            </p:nvGrpSpPr>
+            <p:grpSpPr>
+              <a:xfrm>
+                <a:off x="4115528" y="2823110"/>
+                <a:ext cx="771421" cy="815478"/>
+                <a:chOff x="4115528" y="2823110"/>
+                <a:chExt cx="771421" cy="815478"/>
+              </a:xfrm>
+            </p:grpSpPr>
+            <p:sp>
+              <p:nvSpPr>
+                <p:cNvPr id="34" name="Rectangle 33">
+                  <a:extLst>
+                    <a:ext uri="{FF2B5EF4-FFF2-40B4-BE49-F238E27FC236}">
+                      <a16:creationId xmlns:a16="http://schemas.microsoft.com/office/drawing/2014/main" id="{AC8C008F-40AE-7B56-066D-358A9B134B49}"/>
+                    </a:ext>
+                  </a:extLst>
+                </p:cNvPr>
+                <p:cNvSpPr/>
+                <p:nvPr/>
+              </p:nvSpPr>
+              <p:spPr>
+                <a:xfrm>
+                  <a:off x="4115528" y="3145212"/>
+                  <a:ext cx="771421" cy="279919"/>
+                </a:xfrm>
+                <a:prstGeom prst="rect">
+                  <a:avLst/>
+                </a:prstGeom>
+                <a:solidFill>
+                  <a:schemeClr val="bg1">
+                    <a:lumMod val="95000"/>
+                  </a:schemeClr>
+                </a:solidFill>
+                <a:ln w="19050">
+                  <a:solidFill>
+                    <a:schemeClr val="bg2"/>
+                  </a:solidFill>
+                </a:ln>
+              </p:spPr>
+              <p:style>
+                <a:lnRef idx="2">
+                  <a:schemeClr val="accent1">
+                    <a:shade val="50000"/>
+                  </a:schemeClr>
+                </a:lnRef>
+                <a:fillRef idx="1">
+                  <a:schemeClr val="accent1"/>
+                </a:fillRef>
+                <a:effectRef idx="0">
+                  <a:schemeClr val="accent1"/>
+                </a:effectRef>
+                <a:fontRef idx="minor">
+                  <a:schemeClr val="lt1"/>
+                </a:fontRef>
+              </p:style>
+              <p:txBody>
+                <a:bodyPr lIns="0" rIns="0" rtlCol="0" anchor="ctr"/>
+                <a:lstStyle/>
+                <a:p>
+                  <a:pPr marL="0" marR="0" lvl="0" indent="0" algn="ctr" defTabSz="914400" rtl="0" eaLnBrk="1" fontAlgn="auto" latinLnBrk="0" hangingPunct="1">
+                    <a:lnSpc>
+                      <a:spcPct val="100000"/>
+                    </a:lnSpc>
+                    <a:spcBef>
+                      <a:spcPts val="0"/>
+                    </a:spcBef>
+                    <a:spcAft>
+                      <a:spcPts val="0"/>
+                    </a:spcAft>
+                    <a:buClrTx/>
+                    <a:buSzTx/>
+                    <a:buFontTx/>
+                    <a:buNone/>
+                    <a:tabLst/>
+                    <a:defRPr/>
+                  </a:pPr>
+                  <a:r>
+                    <a:rPr kumimoji="0" lang="en-US" sz="900" b="0" i="0" u="none" strike="noStrike" kern="1200" cap="none" spc="0" normalizeH="0" baseline="0" noProof="0" dirty="0">
+                      <a:ln>
+                        <a:noFill/>
+                      </a:ln>
+                      <a:solidFill>
+                        <a:prstClr val="black"/>
+                      </a:solidFill>
+                      <a:effectLst/>
+                      <a:uLnTx/>
+                      <a:uFillTx/>
+                      <a:ea typeface="+mn-ea"/>
+                      <a:cs typeface="+mn-cs"/>
+                    </a:rPr>
+                    <a:t>Container Platform</a:t>
+                  </a:r>
+                </a:p>
+              </p:txBody>
+            </p:sp>
+            <p:sp>
+              <p:nvSpPr>
+                <p:cNvPr id="35" name="Rectangle: Rounded Corners 34">
+                  <a:extLst>
+                    <a:ext uri="{FF2B5EF4-FFF2-40B4-BE49-F238E27FC236}">
+                      <a16:creationId xmlns:a16="http://schemas.microsoft.com/office/drawing/2014/main" id="{DFBFC135-6FE4-4904-9572-E0043D70EBD6}"/>
+                    </a:ext>
+                  </a:extLst>
+                </p:cNvPr>
+                <p:cNvSpPr/>
+                <p:nvPr/>
+              </p:nvSpPr>
+              <p:spPr>
+                <a:xfrm>
+                  <a:off x="4115528" y="2823110"/>
+                  <a:ext cx="771420" cy="815478"/>
+                </a:xfrm>
+                <a:prstGeom prst="roundRect">
+                  <a:avLst/>
+                </a:prstGeom>
+                <a:noFill/>
+                <a:ln w="19050">
+                  <a:solidFill>
+                    <a:schemeClr val="tx1"/>
+                  </a:solidFill>
+                </a:ln>
+              </p:spPr>
+              <p:style>
+                <a:lnRef idx="2">
+                  <a:schemeClr val="accent1">
+                    <a:shade val="50000"/>
+                  </a:schemeClr>
+                </a:lnRef>
+                <a:fillRef idx="1">
+                  <a:schemeClr val="accent1"/>
+                </a:fillRef>
+                <a:effectRef idx="0">
+                  <a:schemeClr val="accent1"/>
+                </a:effectRef>
+                <a:fontRef idx="minor">
+                  <a:schemeClr val="lt1"/>
+                </a:fontRef>
+              </p:style>
+              <p:txBody>
+                <a:bodyPr lIns="45720" tIns="118872" rtlCol="0" anchor="t" anchorCtr="0"/>
+                <a:lstStyle/>
+                <a:p>
+                  <a:pPr marL="0" marR="0" lvl="0" indent="0" algn="l" defTabSz="914400" rtl="0" eaLnBrk="1" fontAlgn="auto" latinLnBrk="0" hangingPunct="1">
+                    <a:lnSpc>
+                      <a:spcPct val="100000"/>
+                    </a:lnSpc>
+                    <a:spcBef>
+                      <a:spcPts val="0"/>
+                    </a:spcBef>
+                    <a:spcAft>
+                      <a:spcPts val="0"/>
+                    </a:spcAft>
+                    <a:buClrTx/>
+                    <a:buSzTx/>
+                    <a:buFontTx/>
+                    <a:buNone/>
+                    <a:tabLst/>
+                    <a:defRPr/>
+                  </a:pPr>
+                  <a:r>
+                    <a:rPr lang="en-US" sz="800" dirty="0">
+                      <a:solidFill>
+                        <a:prstClr val="black"/>
+                      </a:solidFill>
+                    </a:rPr>
+                    <a:t>cluster-1</a:t>
+                  </a:r>
+                  <a:endParaRPr kumimoji="0" lang="en-US" sz="800" b="0" i="0" u="none" strike="noStrike" kern="1200" cap="none" spc="0" normalizeH="0" baseline="0" noProof="0" dirty="0">
+                    <a:ln>
+                      <a:noFill/>
+                    </a:ln>
+                    <a:solidFill>
+                      <a:prstClr val="black"/>
+                    </a:solidFill>
+                    <a:effectLst/>
+                    <a:uLnTx/>
+                    <a:uFillTx/>
+                    <a:ea typeface="+mn-ea"/>
+                    <a:cs typeface="+mn-cs"/>
+                  </a:endParaRPr>
+                </a:p>
+              </p:txBody>
+            </p:sp>
+          </p:grpSp>
+          <p:sp>
+            <p:nvSpPr>
+              <p:cNvPr id="36" name="Flowchart: Off-page Connector 35">
+                <a:extLst>
+                  <a:ext uri="{FF2B5EF4-FFF2-40B4-BE49-F238E27FC236}">
+                    <a16:creationId xmlns:a16="http://schemas.microsoft.com/office/drawing/2014/main" id="{200F0872-23D3-5A7D-8660-9DA58F7CD82D}"/>
+                  </a:ext>
+                </a:extLst>
+              </p:cNvPr>
+              <p:cNvSpPr/>
+              <p:nvPr/>
+            </p:nvSpPr>
+            <p:spPr>
+              <a:xfrm>
+                <a:off x="4267973" y="3517290"/>
+                <a:ext cx="466531" cy="279919"/>
+              </a:xfrm>
+              <a:prstGeom prst="flowChartOffpageConnector">
+                <a:avLst/>
+              </a:prstGeom>
+              <a:solidFill>
+                <a:schemeClr val="bg1"/>
+              </a:solidFill>
+              <a:ln w="19050">
+                <a:solidFill>
+                  <a:schemeClr val="tx1"/>
+                </a:solidFill>
+              </a:ln>
+            </p:spPr>
+            <p:style>
+              <a:lnRef idx="2">
+                <a:schemeClr val="accent1">
+                  <a:shade val="50000"/>
+                </a:schemeClr>
+              </a:lnRef>
+              <a:fillRef idx="1">
+                <a:schemeClr val="accent1"/>
+              </a:fillRef>
+              <a:effectRef idx="0">
+                <a:schemeClr val="accent1"/>
+              </a:effectRef>
+              <a:fontRef idx="minor">
+                <a:schemeClr val="lt1"/>
+              </a:fontRef>
+            </p:style>
+            <p:txBody>
+              <a:bodyPr tIns="0" rtlCol="0" anchor="t" anchorCtr="0"/>
+              <a:lstStyle/>
+              <a:p>
+                <a:pPr marL="0" marR="0" lvl="0" indent="0" algn="l" defTabSz="914400" rtl="0" eaLnBrk="1" fontAlgn="auto" latinLnBrk="0" hangingPunct="1">
+                  <a:lnSpc>
+                    <a:spcPct val="100000"/>
+                  </a:lnSpc>
+                  <a:spcBef>
+                    <a:spcPts val="0"/>
+                  </a:spcBef>
+                  <a:spcAft>
+                    <a:spcPts val="0"/>
+                  </a:spcAft>
+                  <a:buClrTx/>
+                  <a:buSzTx/>
+                  <a:buFontTx/>
+                  <a:buNone/>
+                  <a:tabLst/>
+                  <a:defRPr/>
+                </a:pPr>
+                <a:endParaRPr kumimoji="0" lang="en-US" sz="1000" b="0" i="0" u="none" strike="noStrike" kern="1200" cap="none" spc="0" normalizeH="0" baseline="0" noProof="0">
+                  <a:ln>
+                    <a:noFill/>
+                  </a:ln>
+                  <a:solidFill>
+                    <a:prstClr val="black"/>
+                  </a:solidFill>
+                  <a:effectLst/>
+                  <a:uLnTx/>
+                  <a:uFillTx/>
+                  <a:ea typeface="+mn-ea"/>
+                  <a:cs typeface="+mn-cs"/>
+                </a:endParaRPr>
+              </a:p>
+            </p:txBody>
+          </p:sp>
+          <p:sp>
+            <p:nvSpPr>
+              <p:cNvPr id="37" name="TextBox 36">
+                <a:extLst>
+                  <a:ext uri="{FF2B5EF4-FFF2-40B4-BE49-F238E27FC236}">
+                    <a16:creationId xmlns:a16="http://schemas.microsoft.com/office/drawing/2014/main" id="{75E9CD42-DACD-5EDE-FB72-AF6D27C6718E}"/>
+                  </a:ext>
+                </a:extLst>
+              </p:cNvPr>
+              <p:cNvSpPr txBox="1"/>
+              <p:nvPr/>
+            </p:nvSpPr>
+            <p:spPr>
+              <a:xfrm>
+                <a:off x="4295092" y="3534139"/>
+                <a:ext cx="412292" cy="230832"/>
+              </a:xfrm>
+              <a:prstGeom prst="rect">
+                <a:avLst/>
+              </a:prstGeom>
+              <a:noFill/>
+            </p:spPr>
+            <p:txBody>
+              <a:bodyPr wrap="square" rtlCol="0">
+                <a:spAutoFit/>
+              </a:bodyPr>
+              <a:lstStyle/>
+              <a:p>
+                <a:pPr marL="0" marR="0" lvl="0" indent="0" algn="l" defTabSz="914400" rtl="0" eaLnBrk="1" fontAlgn="auto" latinLnBrk="0" hangingPunct="1">
+                  <a:lnSpc>
+                    <a:spcPct val="100000"/>
+                  </a:lnSpc>
+                  <a:spcBef>
+                    <a:spcPts val="0"/>
+                  </a:spcBef>
+                  <a:spcAft>
+                    <a:spcPts val="0"/>
+                  </a:spcAft>
+                  <a:buClrTx/>
+                  <a:buSzTx/>
+                  <a:buFontTx/>
+                  <a:buNone/>
+                  <a:tabLst/>
+                  <a:defRPr/>
+                </a:pPr>
+                <a:r>
+                  <a:rPr kumimoji="0" lang="en-US" sz="900" b="0" i="0" u="none" strike="noStrike" kern="1200" cap="none" spc="0" normalizeH="0" baseline="0" noProof="0" dirty="0">
+                    <a:ln>
+                      <a:noFill/>
+                    </a:ln>
+                    <a:solidFill>
+                      <a:prstClr val="black"/>
+                    </a:solidFill>
+                    <a:effectLst/>
+                    <a:uLnTx/>
+                    <a:uFillTx/>
+                    <a:ea typeface="+mn-ea"/>
+                    <a:cs typeface="+mn-cs"/>
+                  </a:rPr>
+                  <a:t>host</a:t>
+                </a:r>
+              </a:p>
+            </p:txBody>
+          </p:sp>
+          <p:grpSp>
+            <p:nvGrpSpPr>
+              <p:cNvPr id="58" name="Group 57">
+                <a:extLst>
+                  <a:ext uri="{FF2B5EF4-FFF2-40B4-BE49-F238E27FC236}">
+                    <a16:creationId xmlns:a16="http://schemas.microsoft.com/office/drawing/2014/main" id="{F6FF56A3-16B1-831C-57CE-9919876BB236}"/>
+                  </a:ext>
+                </a:extLst>
+              </p:cNvPr>
+              <p:cNvGrpSpPr/>
+              <p:nvPr/>
+            </p:nvGrpSpPr>
+            <p:grpSpPr>
+              <a:xfrm>
+                <a:off x="4267973" y="2620040"/>
+                <a:ext cx="466531" cy="351106"/>
+                <a:chOff x="6810318" y="4284899"/>
+                <a:chExt cx="466531" cy="351106"/>
+              </a:xfrm>
+            </p:grpSpPr>
+            <p:sp>
+              <p:nvSpPr>
+                <p:cNvPr id="54" name="Arrow: Chevron 53">
+                  <a:extLst>
+                    <a:ext uri="{FF2B5EF4-FFF2-40B4-BE49-F238E27FC236}">
+                      <a16:creationId xmlns:a16="http://schemas.microsoft.com/office/drawing/2014/main" id="{20E00F62-D32A-8FB7-5FEB-5D3162EC33D3}"/>
+                    </a:ext>
+                  </a:extLst>
+                </p:cNvPr>
+                <p:cNvSpPr/>
+                <p:nvPr/>
+              </p:nvSpPr>
+              <p:spPr>
+                <a:xfrm rot="5400000">
+                  <a:off x="6868031" y="4227186"/>
+                  <a:ext cx="351106" cy="466531"/>
+                </a:xfrm>
+                <a:prstGeom prst="chevron">
+                  <a:avLst>
+                    <a:gd name="adj" fmla="val 14000"/>
+                  </a:avLst>
+                </a:prstGeom>
+                <a:solidFill>
+                  <a:schemeClr val="bg1"/>
+                </a:solidFill>
+                <a:ln w="12700">
+                  <a:solidFill>
+                    <a:schemeClr val="tx1"/>
+                  </a:solidFill>
+                </a:ln>
+              </p:spPr>
+              <p:style>
+                <a:lnRef idx="2">
+                  <a:schemeClr val="accent1">
+                    <a:shade val="50000"/>
+                  </a:schemeClr>
+                </a:lnRef>
+                <a:fillRef idx="1">
+                  <a:schemeClr val="accent1"/>
+                </a:fillRef>
+                <a:effectRef idx="0">
+                  <a:schemeClr val="accent1"/>
+                </a:effectRef>
+                <a:fontRef idx="minor">
+                  <a:schemeClr val="lt1"/>
+                </a:fontRef>
+              </p:style>
+              <p:txBody>
+                <a:bodyPr tIns="0" rtlCol="0" anchor="t" anchorCtr="0"/>
+                <a:lstStyle/>
+                <a:p>
+                  <a:pPr marL="0" marR="0" lvl="0" indent="0" algn="l" defTabSz="914400" rtl="0" eaLnBrk="1" fontAlgn="auto" latinLnBrk="0" hangingPunct="1">
+                    <a:lnSpc>
+                      <a:spcPct val="100000"/>
+                    </a:lnSpc>
+                    <a:spcBef>
+                      <a:spcPts val="0"/>
+                    </a:spcBef>
+                    <a:spcAft>
+                      <a:spcPts val="0"/>
+                    </a:spcAft>
+                    <a:buClrTx/>
+                    <a:buSzTx/>
+                    <a:buFontTx/>
+                    <a:buNone/>
+                    <a:tabLst/>
+                    <a:defRPr/>
+                  </a:pPr>
+                  <a:endParaRPr kumimoji="0" lang="en-US" sz="1000" b="0" i="0" u="none" strike="noStrike" kern="1200" cap="none" spc="0" normalizeH="0" baseline="0" noProof="0">
+                    <a:ln>
+                      <a:noFill/>
+                    </a:ln>
+                    <a:solidFill>
+                      <a:prstClr val="black"/>
+                    </a:solidFill>
+                    <a:effectLst/>
+                    <a:uLnTx/>
+                    <a:uFillTx/>
+                    <a:ea typeface="+mn-ea"/>
+                    <a:cs typeface="+mn-cs"/>
+                  </a:endParaRPr>
+                </a:p>
+              </p:txBody>
+            </p:sp>
+            <p:sp>
+              <p:nvSpPr>
+                <p:cNvPr id="57" name="TextBox 56">
+                  <a:extLst>
+                    <a:ext uri="{FF2B5EF4-FFF2-40B4-BE49-F238E27FC236}">
+                      <a16:creationId xmlns:a16="http://schemas.microsoft.com/office/drawing/2014/main" id="{430F5921-AE55-FC29-BAE4-5A0B0592787C}"/>
+                    </a:ext>
+                  </a:extLst>
+                </p:cNvPr>
+                <p:cNvSpPr txBox="1"/>
+                <p:nvPr/>
+              </p:nvSpPr>
+              <p:spPr>
+                <a:xfrm>
+                  <a:off x="6837438" y="4337341"/>
+                  <a:ext cx="412292" cy="230832"/>
+                </a:xfrm>
+                <a:prstGeom prst="rect">
+                  <a:avLst/>
+                </a:prstGeom>
+                <a:noFill/>
+              </p:spPr>
+              <p:txBody>
+                <a:bodyPr wrap="square" rtlCol="0">
+                  <a:spAutoFit/>
+                </a:bodyPr>
+                <a:lstStyle/>
+                <a:p>
+                  <a:pPr marL="0" marR="0" lvl="0" indent="0" algn="l" defTabSz="914400" rtl="0" eaLnBrk="1" fontAlgn="auto" latinLnBrk="0" hangingPunct="1">
+                    <a:lnSpc>
+                      <a:spcPct val="100000"/>
+                    </a:lnSpc>
+                    <a:spcBef>
+                      <a:spcPts val="0"/>
+                    </a:spcBef>
+                    <a:spcAft>
+                      <a:spcPts val="0"/>
+                    </a:spcAft>
+                    <a:buClrTx/>
+                    <a:buSzTx/>
+                    <a:buFontTx/>
+                    <a:buNone/>
+                    <a:tabLst/>
+                    <a:defRPr/>
+                  </a:pPr>
+                  <a:r>
+                    <a:rPr kumimoji="0" lang="en-US" sz="900" b="0" i="0" u="none" strike="noStrike" kern="1200" cap="none" spc="0" normalizeH="0" baseline="0" noProof="0" dirty="0">
+                      <a:ln>
+                        <a:noFill/>
+                      </a:ln>
+                      <a:solidFill>
+                        <a:prstClr val="black"/>
+                      </a:solidFill>
+                      <a:effectLst/>
+                      <a:uLnTx/>
+                      <a:uFillTx/>
+                      <a:ea typeface="+mn-ea"/>
+                      <a:cs typeface="+mn-cs"/>
+                    </a:rPr>
+                    <a:t>host</a:t>
+                  </a:r>
+                </a:p>
+              </p:txBody>
+            </p:sp>
+          </p:grpSp>
+        </p:grpSp>
+        <p:cxnSp>
+          <p:nvCxnSpPr>
+            <p:cNvPr id="17" name="Straight Arrow Connector 16">
+              <a:extLst>
+                <a:ext uri="{FF2B5EF4-FFF2-40B4-BE49-F238E27FC236}">
+                  <a16:creationId xmlns:a16="http://schemas.microsoft.com/office/drawing/2014/main" id="{E58D11E9-E884-B98D-C7B8-50308964A9BB}"/>
+                </a:ext>
+              </a:extLst>
+            </p:cNvPr>
+            <p:cNvCxnSpPr>
+              <a:cxnSpLocks/>
+            </p:cNvCxnSpPr>
+            <p:nvPr/>
+          </p:nvCxnSpPr>
+          <p:spPr>
+            <a:xfrm flipH="1" flipV="1">
+              <a:off x="6092198" y="4682352"/>
+              <a:ext cx="760" cy="261501"/>
+            </a:xfrm>
+            <a:prstGeom prst="straightConnector1">
+              <a:avLst/>
+            </a:prstGeom>
+            <a:ln w="12700">
+              <a:solidFill>
+                <a:schemeClr val="tx1"/>
+              </a:solidFill>
+              <a:headEnd type="triangle" w="med" len="med"/>
+              <a:tailEnd type="none" w="med" len="med"/>
+            </a:ln>
+          </p:spPr>
+          <p:style>
+            <a:lnRef idx="1">
+              <a:schemeClr val="accent1"/>
+            </a:lnRef>
+            <a:fillRef idx="0">
+              <a:schemeClr val="accent1"/>
+            </a:fillRef>
+            <a:effectRef idx="0">
+              <a:schemeClr val="accent1"/>
+            </a:effectRef>
+            <a:fontRef idx="minor">
+              <a:schemeClr val="tx1"/>
+            </a:fontRef>
+          </p:style>
+        </p:cxnSp>
+      </p:grpSp>
+    </p:spTree>
+    <p:extLst>
+      <p:ext uri="{BB962C8B-B14F-4D97-AF65-F5344CB8AC3E}">
+        <p14:creationId xmlns:p14="http://schemas.microsoft.com/office/powerpoint/2010/main" val="3898307334"/>
       </p:ext>
     </p:extLst>
   </p:cSld>

</xml_diff>